<commit_message>
Trumen Scan: tuned reconstruction (tilt-aware depth alignment, neighbour-view depth check, ground/symmetry axes); accuracy checks in viewer, README and deck
Co-Authored-By: Claude Opus 5.5 <noreply@anthropic.com>

Claude-Session: https://claude.ai/code/session_01FEQgmeREK1hMdVythpmhmn
</commit_message>
<xml_diff>
--- a/guard/deck/Trumen_Guard_defence.pptx
+++ b/guard/deck/Trumen_Guard_defence.pptx
@@ -117,23 +117,23 @@
   <p:extLst>
     <p:ext uri="{521415D9-36F7-43E2-AB2F-B90AF26B5E84}">
       <p14:sectionLst xmlns:p14="http://schemas.microsoft.com/office/powerpoint/2010/main">
-        <p14:section name="Opening" id="{e4b663e9-b3d1-134a-4e48-80db402ccf0a}">
+        <p14:section name="Opening" id="{e108ef9a-6c1a-bfaa-0fab-d824afb5a178}">
           <p14:sldIdLst>
             <p14:sldId id="256"/>
           </p14:sldIdLst>
         </p14:section>
-        <p14:section name="Problem and user" id="{d502d9c1-39d8-c2f6-f025-cbe3dae21b45}">
+        <p14:section name="Problem and user" id="{e3e73498-9af1-f961-3c8c-5ee2d3f52765}">
           <p14:sldIdLst>
             <p14:sldId id="257"/>
             <p14:sldId id="258"/>
           </p14:sldIdLst>
         </p14:section>
-        <p14:section name="Live demo" id="{7dc7e47c-bf2f-2369-5ca6-b9af3246a511}">
+        <p14:section name="Live demo" id="{50890cc3-3b4e-97fd-b40c-20254d42ce9c}">
           <p14:sldIdLst>
             <p14:sldId id="259"/>
           </p14:sldIdLst>
         </p14:section>
-        <p14:section name="Technology" id="{ca49451b-6c35-8f09-dcb2-4af28674d5af}">
+        <p14:section name="Technology" id="{4f7e34ba-6fe5-0c3a-12ad-dfe9435bc5bc}">
           <p14:sldIdLst>
             <p14:sldId id="260"/>
             <p14:sldId id="261"/>
@@ -141,17 +141,17 @@
             <p14:sldId id="263"/>
           </p14:sldIdLst>
         </p14:section>
-        <p14:section name="Budget and ROI" id="{96313b05-b67f-ae4b-864a-465ffa1825de}">
+        <p14:section name="Budget and ROI" id="{31c2685e-2bab-d9c1-c355-12b46f86a6c7}">
           <p14:sldIdLst>
             <p14:sldId id="264"/>
           </p14:sldIdLst>
         </p14:section>
-        <p14:section name="Next product" id="{f003113e-37f2-69e3-c258-a07d7a2795cb}">
+        <p14:section name="Next product" id="{c47f1ae3-a5c2-ecf2-5fdd-f3e18324a568}">
           <p14:sldIdLst>
             <p14:sldId id="265"/>
           </p14:sldIdLst>
         </p14:section>
-        <p14:section name="Next steps" id="{b418f33b-02a4-94fa-c852-04edac3e093f}">
+        <p14:section name="Next steps" id="{7282d8b3-cfad-560e-aa60-b807814c92dc}">
           <p14:sldIdLst>
             <p14:sldId id="266"/>
           </p14:sldIdLst>
@@ -3212,7 +3212,7 @@
                 <a:ea typeface="Calibri" pitchFamily="34" charset="-122"/>
                 <a:cs typeface="Calibri" pitchFamily="34" charset="-120"/>
               </a:rPr>
-              <a:t>95 of 95 views placed; scale from the published length, then width 1.93 m and height 1.36 m vs 1.84 / 1.445 m published. Exported as glTF + JSON for other apps.</a:t>
+              <a:t>95 of 95 views placed. Scale from the published length; then wheelbase +2 mm, width +16 mm, height +4 mm vs published. Exported as glTF + JSON.</a:t>
             </a:r>
             <a:endParaRPr lang="en-US" sz="1500" dirty="0"/>
           </a:p>

</xml_diff>